<commit_message>
docs: align landing site with current SDK and host
</commit_message>
<xml_diff>
--- a/Web3MCP_Pitch_Deck.pptx
+++ b/Web3MCP_Pitch_Deck.pptx
@@ -1266,7 +1266,7 @@
                 <a:ea typeface="Helvetica" pitchFamily="34" charset="-122"/>
                 <a:cs typeface="Helvetica" pitchFamily="34" charset="-120"/>
               </a:rPr>
-              <a:t>PROTOCOL SPECIFICATION v0.1.0 · STRICT ON-CHAIN DISCOVERY</a:t>
+              <a:t>CANDIDATE v0.1 · v0.2 READ EXTENSION · ON-CHAIN DISCOVERY</a:t>
             </a:r>
             <a:endParaRPr lang="en-US" sz="750" dirty="0"/>
           </a:p>
@@ -1749,7 +1749,7 @@
                 <a:ea typeface="Helvetica" pitchFamily="34" charset="-122"/>
                 <a:cs typeface="Helvetica" pitchFamily="34" charset="-120"/>
               </a:rPr>
-              <a:t>Open-source specification · reference implementation · frozen v0.1</a:t>
+              <a:t>Candidate specification · Devnet reference program · compatible host</a:t>
             </a:r>
             <a:endParaRPr lang="en-US" sz="1100" dirty="0"/>
           </a:p>
@@ -2509,7 +2509,7 @@
                 <a:ea typeface="Helvetica" pitchFamily="34" charset="-122"/>
                 <a:cs typeface="Helvetica" pitchFamily="34" charset="-120"/>
               </a:rPr>
-              <a:t>ZERO ON-CHAIN PROOF</a:t>
+              <a:t>CUSTOM INTEGRATIONS</a:t>
             </a:r>
             <a:endParaRPr lang="en-US" sz="1100" dirty="0"/>
           </a:p>
@@ -2548,7 +2548,7 @@
                 <a:ea typeface="Helvetica" pitchFamily="34" charset="-122"/>
                 <a:cs typeface="Helvetica" pitchFamily="34" charset="-120"/>
               </a:rPr>
-              <a:t>No cryptographic verification of tools</a:t>
+              <a:t>Tool descriptions vary by server</a:t>
             </a:r>
             <a:endParaRPr lang="en-US" sz="1000" dirty="0"/>
           </a:p>
@@ -3219,7 +3219,7 @@
                 <a:ea typeface="Helvetica" pitchFamily="34" charset="-122"/>
                 <a:cs typeface="Helvetica" pitchFamily="34" charset="-120"/>
               </a:rPr>
-              <a:t>ZERO MIDDLEWARE</a:t>
+              <a:t>DIRECT DISCOVERY</a:t>
             </a:r>
             <a:endParaRPr lang="en-US" sz="1000" dirty="0"/>
           </a:p>
@@ -3258,7 +3258,7 @@
                 <a:ea typeface="Helvetica" pitchFamily="34" charset="-122"/>
                 <a:cs typeface="Helvetica" pitchFamily="34" charset="-120"/>
               </a:rPr>
-              <a:t>No servers, no web scraping, no third-party APIs</a:t>
+              <a:t>No project-specific MCP server or website required</a:t>
             </a:r>
             <a:endParaRPr lang="en-US" sz="950" dirty="0"/>
           </a:p>
@@ -3425,7 +3425,7 @@
                 <a:ea typeface="Helvetica" pitchFamily="34" charset="-122"/>
                 <a:cs typeface="Helvetica" pitchFamily="34" charset="-120"/>
               </a:rPr>
-              <a:t>STRICT DECOUPLING</a:t>
+              <a:t>GENERIC HOST</a:t>
             </a:r>
             <a:endParaRPr lang="en-US" sz="1000" dirty="0"/>
           </a:p>
@@ -3464,7 +3464,7 @@
                 <a:ea typeface="Helvetica" pitchFamily="34" charset="-122"/>
                 <a:cs typeface="Helvetica" pitchFamily="34" charset="-120"/>
               </a:rPr>
-              <a:t>Host never imports program source or IDL (ADR 0007)</a:t>
+              <a:t>Host reads the embedded IDL from the config PDA</a:t>
             </a:r>
             <a:endParaRPr lang="en-US" sz="950" dirty="0"/>
           </a:p>
@@ -3631,7 +3631,7 @@
                 <a:ea typeface="Helvetica" pitchFamily="34" charset="-122"/>
                 <a:cs typeface="Helvetica" pitchFamily="34" charset="-120"/>
               </a:rPr>
-              <a:t>AGENT / LLM RUNTIME</a:t>
+              <a:t>MODEL + HOST RUNTIME</a:t>
             </a:r>
             <a:endParaRPr lang="en-US" sz="950" dirty="0"/>
           </a:p>
@@ -3787,7 +3787,7 @@
                 <a:ea typeface="Helvetica" pitchFamily="34" charset="-122"/>
                 <a:cs typeface="Helvetica" pitchFamily="34" charset="-120"/>
               </a:rPr>
-              <a:t>✓ Simulates transaction effects</a:t>
+              <a:t>✓ Host simulates proposed transaction</a:t>
             </a:r>
             <a:endParaRPr lang="en-US" sz="1000" dirty="0"/>
           </a:p>
@@ -3963,7 +3963,7 @@
                 <a:ea typeface="Helvetica" pitchFamily="34" charset="-122"/>
                 <a:cs typeface="Helvetica" pitchFamily="34" charset="-120"/>
               </a:rPr>
-              <a:t>HUMAN WALLET</a:t>
+              <a:t>HOST + USER</a:t>
             </a:r>
             <a:endParaRPr lang="en-US" sz="950" dirty="0"/>
           </a:p>
@@ -4002,7 +4002,7 @@
                 <a:ea typeface="Helvetica" pitchFamily="34" charset="-122"/>
                 <a:cs typeface="Helvetica" pitchFamily="34" charset="-120"/>
               </a:rPr>
-              <a:t>Sole Signing Authority</a:t>
+              <a:t>Local keypair approval</a:t>
             </a:r>
             <a:endParaRPr lang="en-US" sz="1500" dirty="0"/>
           </a:p>
@@ -4041,7 +4041,7 @@
                 <a:ea typeface="Helvetica" pitchFamily="34" charset="-122"/>
                 <a:cs typeface="Helvetica" pitchFamily="34" charset="-120"/>
               </a:rPr>
-              <a:t>✓ Reviews exact accounts &amp; lamports</a:t>
+              <a:t>✓ Reviews program, accounts &amp; arguments</a:t>
             </a:r>
             <a:endParaRPr lang="en-US" sz="1000" dirty="0"/>
           </a:p>
@@ -4080,7 +4080,7 @@
                 <a:ea typeface="Helvetica" pitchFamily="34" charset="-122"/>
                 <a:cs typeface="Helvetica" pitchFamily="34" charset="-120"/>
               </a:rPr>
-              <a:t>✓ Inspects simulation &amp; network fee</a:t>
+              <a:t>✓ Inspects simulation &amp; fee estimate</a:t>
             </a:r>
             <a:endParaRPr lang="en-US" sz="1000" dirty="0"/>
           </a:p>
@@ -4119,7 +4119,7 @@
                 <a:ea typeface="Helvetica" pitchFamily="34" charset="-122"/>
                 <a:cs typeface="Helvetica" pitchFamily="34" charset="-120"/>
               </a:rPr>
-              <a:t>✓ Explicit human cryptographic sign</a:t>
+              <a:t>✓ Presses s to sign with selected keypair</a:t>
             </a:r>
             <a:endParaRPr lang="en-US" sz="1000" dirty="0"/>
           </a:p>
@@ -4158,7 +4158,7 @@
                 <a:ea typeface="Helvetica" pitchFamily="34" charset="-122"/>
                 <a:cs typeface="Helvetica" pitchFamily="34" charset="-120"/>
               </a:rPr>
-              <a:t>⚡ IMMUTABLE CLUSTER BROADCAST</a:t>
+              <a:t>⚡ HOST SUBMITS SIGNED TRANSACTION</a:t>
             </a:r>
             <a:endParaRPr lang="en-US" sz="1000" dirty="0"/>
           </a:p>
@@ -4325,7 +4325,7 @@
                 <a:ea typeface="Helvetica" pitchFamily="34" charset="-122"/>
                 <a:cs typeface="Helvetica" pitchFamily="34" charset="-120"/>
               </a:rPr>
-              <a:t>9</a:t>
+              <a:t>5</a:t>
             </a:r>
             <a:endParaRPr lang="en-US" sz="3200" dirty="0"/>
           </a:p>
@@ -4364,7 +4364,7 @@
                 <a:ea typeface="Helvetica" pitchFamily="34" charset="-122"/>
                 <a:cs typeface="Helvetica" pitchFamily="34" charset="-120"/>
               </a:rPr>
-              <a:t>CHUNKS STREAMED</a:t>
+              <a:t>PUBLISHED TOOLS</a:t>
             </a:r>
             <a:endParaRPr lang="en-US" sz="850" dirty="0"/>
           </a:p>
@@ -4428,7 +4428,7 @@
                 <a:ea typeface="Helvetica" pitchFamily="34" charset="-122"/>
                 <a:cs typeface="Helvetica" pitchFamily="34" charset="-120"/>
               </a:rPr>
-              <a:t>6.7KB</a:t>
+              <a:t>v0.2</a:t>
             </a:r>
             <a:endParaRPr lang="en-US" sz="3200" dirty="0"/>
           </a:p>
@@ -4467,7 +4467,7 @@
                 <a:ea typeface="Helvetica" pitchFamily="34" charset="-122"/>
                 <a:cs typeface="Helvetica" pitchFamily="34" charset="-120"/>
               </a:rPr>
-              <a:t>IDL &amp; TOOL MANIFEST</a:t>
+              <a:t>READ PDA EXTENSION</a:t>
             </a:r>
             <a:endParaRPr lang="en-US" sz="850" dirty="0"/>
           </a:p>
@@ -4531,7 +4531,7 @@
                 <a:ea typeface="Helvetica" pitchFamily="34" charset="-122"/>
                 <a:cs typeface="Helvetica" pitchFamily="34" charset="-120"/>
               </a:rPr>
-              <a:t>100%</a:t>
+              <a:t>SHA-256</a:t>
             </a:r>
             <a:endParaRPr lang="en-US" sz="3200" dirty="0"/>
           </a:p>
@@ -4570,7 +4570,7 @@
                 <a:ea typeface="Helvetica" pitchFamily="34" charset="-122"/>
                 <a:cs typeface="Helvetica" pitchFamily="34" charset="-120"/>
               </a:rPr>
-              <a:t>SHA-256 INTEGRITY</a:t>
+              <a:t>PAYLOAD DIGEST</a:t>
             </a:r>
             <a:endParaRPr lang="en-US" sz="850" dirty="0"/>
           </a:p>
@@ -4673,7 +4673,7 @@
                 <a:ea typeface="Helvetica" pitchFamily="34" charset="-122"/>
                 <a:cs typeface="Helvetica" pitchFamily="34" charset="-120"/>
               </a:rPr>
-              <a:t>GgVnzvsMhHHKeeGnqQhU9KAjBeCVhYiYmR17174Lyrgv</a:t>
+              <a:t>9zJzM4rHDPR4pd3vXHQjQ7whTVmx4zxB3ZH4Gb9iXRwD</a:t>
             </a:r>
             <a:endParaRPr lang="en-US" sz="1000" dirty="0"/>
           </a:p>
@@ -4751,7 +4751,7 @@
                 <a:ea typeface="Helvetica" pitchFamily="34" charset="-122"/>
                 <a:cs typeface="Helvetica" pitchFamily="34" charset="-120"/>
               </a:rPr>
-              <a:t>HfA1ExZS1cgYR5k5GEJmsQfyAcDK2J9NPi7p97dU3WLD  (seeds: ["web3mcp", "config"])</a:t>
+              <a:t>J8Ph37LoQsv4yED6USdupCooCZzsVMqJkgBTm9uSkvCw  (seeds: ["web3mcp", "config"])</a:t>
             </a:r>
             <a:endParaRPr lang="en-US" sz="1000" dirty="0"/>
           </a:p>
@@ -4790,7 +4790,7 @@
                 <a:ea typeface="Helvetica" pitchFamily="34" charset="-122"/>
                 <a:cs typeface="Helvetica" pitchFamily="34" charset="-120"/>
               </a:rPr>
-              <a:t>VERIFIED TOOLS</a:t>
+              <a:t>PUBLISHED TOOLS</a:t>
             </a:r>
             <a:endParaRPr lang="en-US" sz="850" dirty="0"/>
           </a:p>
@@ -4821,7 +4821,7 @@
               <a:buNone/>
             </a:pPr>
             <a:r>
-              <a:rPr lang="en-US" sz="1000" dirty="0">
+              <a:rPr lang="en-US" sz="900" dirty="0">
                 <a:solidFill>
                   <a:srgbClr val="8E929A"/>
                 </a:solidFill>
@@ -4829,9 +4829,9 @@
                 <a:ea typeface="Helvetica" pitchFamily="34" charset="-122"/>
                 <a:cs typeface="Helvetica" pitchFamily="34" charset="-120"/>
               </a:rPr>
-              <a:t>get_vault (read) · initialize, deposit, withdraw (instructions)</a:t>
-            </a:r>
-            <a:endParaRPr lang="en-US" sz="1000" dirty="0"/>
+              <a:t>get_vault, get_vault_by_owner (reads) · initialize, deposit, withdraw</a:t>
+            </a:r>
+            <a:endParaRPr lang="en-US" sz="900" dirty="0"/>
           </a:p>
         </p:txBody>
       </p:sp>
@@ -4932,7 +4932,7 @@
                 <a:ea typeface="Playfair Display" pitchFamily="34" charset="-122"/>
                 <a:cs typeface="Playfair Display" pitchFamily="34" charset="-120"/>
               </a:rPr>
-              <a:t>From Protocol Freeze to Production</a:t>
+              <a:t>From Candidate Protocol to Interoperability Demo</a:t>
             </a:r>
             <a:endParaRPr lang="en-US" sz="3000" dirty="0"/>
           </a:p>
@@ -5035,7 +5035,7 @@
                 <a:ea typeface="Helvetica" pitchFamily="34" charset="-122"/>
                 <a:cs typeface="Helvetica" pitchFamily="34" charset="-120"/>
               </a:rPr>
-              <a:t>FROZEN</a:t>
+              <a:t>REVIEW</a:t>
             </a:r>
             <a:endParaRPr lang="en-US" sz="850" dirty="0"/>
           </a:p>
@@ -5416,7 +5416,7 @@
             <a:r>
               <a:rPr lang="en-US" sz="2400" b="1" dirty="0">
                 <a:solidFill>
-                  <a:srgbClr val="8E929A"/>
+                  <a:srgbClr val="FFFFFF"/>
                 </a:solidFill>
                 <a:latin typeface="Helvetica" pitchFamily="34" charset="0"/>
                 <a:ea typeface="Helvetica" pitchFamily="34" charset="-122"/>
@@ -5455,13 +5455,13 @@
             <a:r>
               <a:rPr lang="en-US" sz="850" b="1" spc="150" kern="0" dirty="0">
                 <a:solidFill>
-                  <a:srgbClr val="8E929A"/>
-                </a:solidFill>
-                <a:latin typeface="Helvetica" pitchFamily="34" charset="0"/>
-                <a:ea typeface="Helvetica" pitchFamily="34" charset="-122"/>
-                <a:cs typeface="Helvetica" pitchFamily="34" charset="-120"/>
-              </a:rPr>
-              <a:t>NEXT</a:t>
+                  <a:srgbClr val="FFFFFF"/>
+                </a:solidFill>
+                <a:latin typeface="Helvetica" pitchFamily="34" charset="0"/>
+                <a:ea typeface="Helvetica" pitchFamily="34" charset="-122"/>
+                <a:cs typeface="Helvetica" pitchFamily="34" charset="-120"/>
+              </a:rPr>
+              <a:t>ACTIVE</a:t>
             </a:r>
             <a:endParaRPr lang="en-US" sz="850" dirty="0"/>
           </a:p>
@@ -5603,7 +5603,7 @@
                 <a:ea typeface="Helvetica" pitchFamily="34" charset="-122"/>
                 <a:cs typeface="Helvetica" pitchFamily="34" charset="-120"/>
               </a:rPr>
-              <a:t>Q1</a:t>
+              <a:t>PENDING</a:t>
             </a:r>
             <a:endParaRPr lang="en-US" sz="850" dirty="0"/>
           </a:p>
@@ -5642,7 +5642,7 @@
                 <a:ea typeface="Helvetica" pitchFamily="34" charset="-122"/>
                 <a:cs typeface="Helvetica" pitchFamily="34" charset="-120"/>
               </a:rPr>
-              <a:t>DEMO</a:t>
+              <a:t>2ND PROG</a:t>
             </a:r>
             <a:endParaRPr lang="en-US" sz="1300" dirty="0"/>
           </a:p>
@@ -5706,7 +5706,7 @@
                 <a:ea typeface="Helvetica" pitchFamily="34" charset="-122"/>
                 <a:cs typeface="Helvetica" pitchFamily="34" charset="-120"/>
               </a:rPr>
-              <a:t>THE OPEN STANDARD</a:t>
+              <a:t>OPEN PROTOCOL CANDIDATE</a:t>
             </a:r>
             <a:endParaRPr lang="en-US" sz="1100" dirty="0"/>
           </a:p>

</xml_diff>